<commit_message>
Investor deck v2: founder, why-not-Excel, market (sourced or 'under research'), demo QR; tech proof folded into stage; video v2 sources (bigger phone, zoom, QR end card)
Co-Authored-By: Claude Opus 5.5 <noreply@anthropic.com>
Claude-Session: https://claude.ai/code/session_0167YBnd3mkvB2ZSHdrC1V6N
</commit_message>
<xml_diff>
--- a/docs/company/investor/idarati-investor-deck.pptx
+++ b/docs/company/investor/idarati-investor-deck.pptx
@@ -16,6 +16,8 @@
     <p:sldId id="264" r:id="rId16"/>
     <p:sldId id="265" r:id="rId17"/>
     <p:sldId id="266" r:id="rId18"/>
+    <p:sldId id="267" r:id="rId19"/>
+    <p:sldId id="268" r:id="rId20"/>
   </p:sldIdLst>
   <p:sldSz cx="12192000" cy="6858000" type="screen4x3"/>
   <p:notesSz cx="6858000" cy="9144000"/>
@@ -582,7 +584,7 @@
           <a:lstStyle/>
           <a:p>
             <a:r>
-              <a:t>الطلب صغير ومحدد عمداً. المبلغ بين القوسين يحدده محمد قبل العرض: أتعاب المحامي ما انعرفت للحين.</a:t>
+              <a:t>المستثمر بمرحلة قبل المستخدمين يشتري المؤسس. أضف صورتك مكان الدائرة، وجملة وحدة: ليش هالمشكلة تهمك شخصياً. تأكد إن كل سطر هني صحيح قبل الإرسال.</a:t>
             </a:r>
           </a:p>
         </p:txBody>
@@ -652,6 +654,146 @@
           <a:lstStyle/>
           <a:p>
             <a:r>
+              <a:t>ما عندنا سعر ولا نتوقع إيراد. الخيارات مطروحة للنقاش، والقرار بعد ما نشوف العائلات شلون تستخدمه. التكاليف الوحيدة المؤكدة: أبل 99 دولار بالسنة (حوالي 37.3 د.ب) وقوقل 25 دولار مرة (حوالي 9.4 د.ب).</a:t>
+            </a:r>
+          </a:p>
+        </p:txBody>
+      </p:sp>
+      <p:sp>
+        <p:nvSpPr>
+          <p:cNvPr id="4" name="Slide Number Placeholder 3"/>
+          <p:cNvSpPr>
+            <a:spLocks noGrp="1"/>
+          </p:cNvSpPr>
+          <p:nvPr>
+            <p:ph type="sldNum" idx="5" sz="quarter"/>
+          </p:nvPr>
+        </p:nvSpPr>
+        <p:spPr/>
+      </p:sp>
+    </p:spTree>
+  </p:cSld>
+  <p:clrMapOvr>
+    <a:masterClrMapping/>
+  </p:clrMapOvr>
+</p:notes>
+</file>
+
+<file path=ppt/notesSlides/notesSlide12.xml><?xml version="1.0" encoding="utf-8"?>
+<p:notes xmlns:a="http://schemas.openxmlformats.org/drawingml/2006/main" xmlns:p="http://schemas.openxmlformats.org/presentationml/2006/main" xmlns:r="http://schemas.openxmlformats.org/officeDocument/2006/relationships">
+  <p:cSld>
+    <p:spTree>
+      <p:nvGrpSpPr>
+        <p:cNvPr id="1" name=""/>
+        <p:cNvGrpSpPr/>
+        <p:nvPr/>
+      </p:nvGrpSpPr>
+      <p:grpSpPr>
+        <a:xfrm>
+          <a:off x="0" y="0"/>
+          <a:ext cx="0" cy="0"/>
+          <a:chOff x="0" y="0"/>
+          <a:chExt cx="0" cy="0"/>
+        </a:xfrm>
+      </p:grpSpPr>
+      <p:sp>
+        <p:nvSpPr>
+          <p:cNvPr id="2" name="Slide Image Placeholder 1"/>
+          <p:cNvSpPr>
+            <a:spLocks noGrp="1"/>
+          </p:cNvSpPr>
+          <p:nvPr>
+            <p:ph type="sldImg" idx="2"/>
+          </p:nvPr>
+        </p:nvSpPr>
+        <p:spPr/>
+      </p:sp>
+      <p:sp>
+        <p:nvSpPr>
+          <p:cNvPr id="3" name="Notes Placeholder 2"/>
+          <p:cNvSpPr>
+            <a:spLocks noGrp="1"/>
+          </p:cNvSpPr>
+          <p:nvPr>
+            <p:ph type="body" idx="3" sz="quarter"/>
+          </p:nvPr>
+        </p:nvSpPr>
+        <p:spPr/>
+        <p:txBody>
+          <a:bodyPr/>
+          <a:lstStyle/>
+          <a:p>
+            <a:r>
+              <a:t>الطلب صغير ومحدد عمداً. المبلغ بين القوسين يحدده محمد قبل العرض: أتعاب المحامي ما انعرفت للحين.</a:t>
+            </a:r>
+          </a:p>
+        </p:txBody>
+      </p:sp>
+      <p:sp>
+        <p:nvSpPr>
+          <p:cNvPr id="4" name="Slide Number Placeholder 3"/>
+          <p:cNvSpPr>
+            <a:spLocks noGrp="1"/>
+          </p:cNvSpPr>
+          <p:nvPr>
+            <p:ph type="sldNum" idx="5" sz="quarter"/>
+          </p:nvPr>
+        </p:nvSpPr>
+        <p:spPr/>
+      </p:sp>
+    </p:spTree>
+  </p:cSld>
+  <p:clrMapOvr>
+    <a:masterClrMapping/>
+  </p:clrMapOvr>
+</p:notes>
+</file>
+
+<file path=ppt/notesSlides/notesSlide13.xml><?xml version="1.0" encoding="utf-8"?>
+<p:notes xmlns:a="http://schemas.openxmlformats.org/drawingml/2006/main" xmlns:p="http://schemas.openxmlformats.org/presentationml/2006/main" xmlns:r="http://schemas.openxmlformats.org/officeDocument/2006/relationships">
+  <p:cSld>
+    <p:spTree>
+      <p:nvGrpSpPr>
+        <p:cNvPr id="1" name=""/>
+        <p:cNvGrpSpPr/>
+        <p:nvPr/>
+      </p:nvGrpSpPr>
+      <p:grpSpPr>
+        <a:xfrm>
+          <a:off x="0" y="0"/>
+          <a:ext cx="0" cy="0"/>
+          <a:chOff x="0" y="0"/>
+          <a:chExt cx="0" cy="0"/>
+        </a:xfrm>
+      </p:grpSpPr>
+      <p:sp>
+        <p:nvSpPr>
+          <p:cNvPr id="2" name="Slide Image Placeholder 1"/>
+          <p:cNvSpPr>
+            <a:spLocks noGrp="1"/>
+          </p:cNvSpPr>
+          <p:nvPr>
+            <p:ph type="sldImg" idx="2"/>
+          </p:nvPr>
+        </p:nvSpPr>
+        <p:spPr/>
+      </p:sp>
+      <p:sp>
+        <p:nvSpPr>
+          <p:cNvPr id="3" name="Notes Placeholder 2"/>
+          <p:cNvSpPr>
+            <a:spLocks noGrp="1"/>
+          </p:cNvSpPr>
+          <p:nvPr>
+            <p:ph type="body" idx="3" sz="quarter"/>
+          </p:nvPr>
+        </p:nvSpPr>
+        <p:spPr/>
+        <p:txBody>
+          <a:bodyPr/>
+          <a:lstStyle/>
+          <a:p>
+            <a:r>
               <a:t>اختم بدعوة للتجربة، مو بوعد. حط رقمك وإيميلك مكان الأقواس قبل الإرسال.</a:t>
             </a:r>
           </a:p>
@@ -1002,7 +1144,7 @@
           <a:lstStyle/>
           <a:p>
             <a:r>
-              <a:t>الخصوصية ميزة بيع للعائلات. ملاحظة صريحة: سياسة الخصوصية مكتوبة وتنتظر مراجعة محامي مرخّص قبل أي نشر عام، والبيانات المتزامنة محفوظة بسيرفر Supabase بطوكيو.</a:t>
+              <a:t>المقارنة مع الأدوات اللي العائلات تستخدمها فعلاً، مو مع تطبيقات منافسة بالاسم — ما قارنّاها بشكل موثّق للحين. لو المستثمر سأل عن منافس معيّن: «نرجع لك بمقارنة».</a:t>
             </a:r>
           </a:p>
         </p:txBody>
@@ -1072,7 +1214,7 @@
           <a:lstStyle/>
           <a:p>
             <a:r>
-              <a:t>الأرقام من المشروع نفسه وقت تجهيز العرض. 197 فحص بالمتصفح، 41 فحص أمان لقاعدة البيانات. آيفون يفتح بالسميوليتر بنجاح؛ اختبار محاكي أندرويد انضاف حديثاً.</a:t>
+              <a:t>ما نحط رقم ما تحققنا منه. الرقم الرسمي موجود بتعداد 2020 وبنحطه بعد ما نراجعه من مصدره.</a:t>
             </a:r>
           </a:p>
         </p:txBody>
@@ -1142,7 +1284,7 @@
           <a:lstStyle/>
           <a:p>
             <a:r>
-              <a:t>قلها قبل ما ينسأل: ما فيه مستخدمين للحين. اللي نعرضه منتج شغّال ومختبر، والخطوة الجاية تجربة حقيقية. بدون تاريخ إطلاق.</a:t>
+              <a:t>الخصوصية ميزة بيع للعائلات. ملاحظة صريحة: سياسة الخصوصية مكتوبة وتنتظر مراجعة محامي مرخّص قبل أي نشر عام، والبيانات المتزامنة محفوظة بسيرفر Supabase بطوكيو.</a:t>
             </a:r>
           </a:p>
         </p:txBody>
@@ -1212,7 +1354,7 @@
           <a:lstStyle/>
           <a:p>
             <a:r>
-              <a:t>ما عندنا سعر ولا نتوقع إيراد. الخيارات مطروحة للنقاش، والقرار بعد ما نشوف العائلات شلون تستخدمه. التكاليف الوحيدة المؤكدة: أبل 99 دولار بالسنة (حوالي 37.3 د.ب) وقوقل 25 دولار مرة (حوالي 9.4 د.ب).</a:t>
+              <a:t>قلها قبل ما ينسأل: ما فيه مستخدمين للحين. اللي نعرضه منتج شغّال ومختبر، والخطوة الجاية تجربة حقيقية. بدون تاريخ إطلاق.</a:t>
             </a:r>
           </a:p>
         </p:txBody>
@@ -4305,6 +4447,90 @@
       <p:pic>
         <p:nvPicPr>
           <p:cNvPr id="2" name="Picture 1" descr="slide-11.png"/>
+          <p:cNvPicPr>
+            <a:picLocks noChangeAspect="1"/>
+          </p:cNvPicPr>
+          <p:nvPr/>
+        </p:nvPicPr>
+        <p:blipFill>
+          <a:blip r:embed="rId2"/>
+          <a:stretch>
+            <a:fillRect/>
+          </a:stretch>
+        </p:blipFill>
+        <p:spPr>
+          <a:xfrm>
+            <a:off x="0" y="0"/>
+            <a:ext cx="12192000" cy="6858000"/>
+          </a:xfrm>
+          <a:prstGeom prst="rect">
+            <a:avLst/>
+          </a:prstGeom>
+        </p:spPr>
+      </p:pic>
+    </p:spTree>
+  </p:cSld>
+  <p:clrMapOvr>
+    <a:masterClrMapping/>
+  </p:clrMapOvr>
+</p:sld>
+</file>
+
+<file path=ppt/slides/slide12.xml><?xml version="1.0" encoding="utf-8"?>
+<p:sld xmlns:a="http://schemas.openxmlformats.org/drawingml/2006/main" xmlns:p="http://schemas.openxmlformats.org/presentationml/2006/main" xmlns:r="http://schemas.openxmlformats.org/officeDocument/2006/relationships">
+  <p:cSld>
+    <p:spTree>
+      <p:nvGrpSpPr>
+        <p:cNvPr id="1" name=""/>
+        <p:cNvGrpSpPr/>
+        <p:nvPr/>
+      </p:nvGrpSpPr>
+      <p:grpSpPr/>
+      <p:pic>
+        <p:nvPicPr>
+          <p:cNvPr id="2" name="Picture 1" descr="slide-12.png"/>
+          <p:cNvPicPr>
+            <a:picLocks noChangeAspect="1"/>
+          </p:cNvPicPr>
+          <p:nvPr/>
+        </p:nvPicPr>
+        <p:blipFill>
+          <a:blip r:embed="rId2"/>
+          <a:stretch>
+            <a:fillRect/>
+          </a:stretch>
+        </p:blipFill>
+        <p:spPr>
+          <a:xfrm>
+            <a:off x="0" y="0"/>
+            <a:ext cx="12192000" cy="6858000"/>
+          </a:xfrm>
+          <a:prstGeom prst="rect">
+            <a:avLst/>
+          </a:prstGeom>
+        </p:spPr>
+      </p:pic>
+    </p:spTree>
+  </p:cSld>
+  <p:clrMapOvr>
+    <a:masterClrMapping/>
+  </p:clrMapOvr>
+</p:sld>
+</file>
+
+<file path=ppt/slides/slide13.xml><?xml version="1.0" encoding="utf-8"?>
+<p:sld xmlns:a="http://schemas.openxmlformats.org/drawingml/2006/main" xmlns:p="http://schemas.openxmlformats.org/presentationml/2006/main" xmlns:r="http://schemas.openxmlformats.org/officeDocument/2006/relationships">
+  <p:cSld>
+    <p:spTree>
+      <p:nvGrpSpPr>
+        <p:cNvPr id="1" name=""/>
+        <p:cNvGrpSpPr/>
+        <p:nvPr/>
+      </p:nvGrpSpPr>
+      <p:grpSpPr/>
+      <p:pic>
+        <p:nvPicPr>
+          <p:cNvPr id="2" name="Picture 1" descr="slide-13.png"/>
           <p:cNvPicPr>
             <a:picLocks noChangeAspect="1"/>
           </p:cNvPicPr>

</xml_diff>